<commit_message>
Final updates to final presentation to match video.
</commit_message>
<xml_diff>
--- a/presentation/final-presentation.pptx
+++ b/presentation/final-presentation.pptx
@@ -4,17 +4,19 @@
   <p:sldMasterIdLst>
     <p:sldMasterId id="2147483648" r:id="rId1"/>
   </p:sldMasterIdLst>
+  <p:notesMasterIdLst>
+    <p:notesMasterId r:id="rId11"/>
+  </p:notesMasterIdLst>
   <p:sldIdLst>
     <p:sldId id="256" r:id="rId2"/>
     <p:sldId id="257" r:id="rId3"/>
     <p:sldId id="258" r:id="rId4"/>
     <p:sldId id="259" r:id="rId5"/>
-    <p:sldId id="260" r:id="rId6"/>
-    <p:sldId id="261" r:id="rId7"/>
-    <p:sldId id="262" r:id="rId8"/>
-    <p:sldId id="263" r:id="rId9"/>
-    <p:sldId id="264" r:id="rId10"/>
-    <p:sldId id="265" r:id="rId11"/>
+    <p:sldId id="261" r:id="rId6"/>
+    <p:sldId id="262" r:id="rId7"/>
+    <p:sldId id="263" r:id="rId8"/>
+    <p:sldId id="264" r:id="rId9"/>
+    <p:sldId id="265" r:id="rId10"/>
   </p:sldIdLst>
   <p:sldSz cx="12192000" cy="6858000"/>
   <p:notesSz cx="6858000" cy="9144000"/>
@@ -113,7 +115,445 @@
       </a:defRPr>
     </a:lvl9pPr>
   </p:defaultTextStyle>
+  <p:extLst>
+    <p:ext uri="{EFAFB233-063F-42B5-8137-9DF3F51BA10A}">
+      <p15:sldGuideLst xmlns:p15="http://schemas.microsoft.com/office/powerpoint/2012/main"/>
+    </p:ext>
+  </p:extLst>
 </p:presentation>
+</file>
+
+<file path=ppt/notesMasters/notesMaster1.xml><?xml version="1.0" encoding="utf-8"?>
+<p:notesMaster xmlns:a="http://schemas.openxmlformats.org/drawingml/2006/main" xmlns:r="http://schemas.openxmlformats.org/officeDocument/2006/relationships" xmlns:p="http://schemas.openxmlformats.org/presentationml/2006/main">
+  <p:cSld>
+    <p:bg>
+      <p:bgRef idx="1001">
+        <a:schemeClr val="bg1"/>
+      </p:bgRef>
+    </p:bg>
+    <p:spTree>
+      <p:nvGrpSpPr>
+        <p:cNvPr id="1" name=""/>
+        <p:cNvGrpSpPr/>
+        <p:nvPr/>
+      </p:nvGrpSpPr>
+      <p:grpSpPr>
+        <a:xfrm>
+          <a:off x="0" y="0"/>
+          <a:ext cx="0" cy="0"/>
+          <a:chOff x="0" y="0"/>
+          <a:chExt cx="0" cy="0"/>
+        </a:xfrm>
+      </p:grpSpPr>
+      <p:sp>
+        <p:nvSpPr>
+          <p:cNvPr id="2" name="Header Placeholder 1"/>
+          <p:cNvSpPr>
+            <a:spLocks noGrp="1"/>
+          </p:cNvSpPr>
+          <p:nvPr>
+            <p:ph type="hdr" sz="quarter"/>
+          </p:nvPr>
+        </p:nvSpPr>
+        <p:spPr>
+          <a:xfrm>
+            <a:off x="0" y="0"/>
+            <a:ext cx="2971800" cy="458788"/>
+          </a:xfrm>
+          <a:prstGeom prst="rect">
+            <a:avLst/>
+          </a:prstGeom>
+        </p:spPr>
+        <p:txBody>
+          <a:bodyPr vert="horz" lIns="91440" tIns="45720" rIns="91440" bIns="45720" rtlCol="0"/>
+          <a:lstStyle>
+            <a:lvl1pPr algn="l">
+              <a:defRPr sz="1200"/>
+            </a:lvl1pPr>
+          </a:lstStyle>
+          <a:p>
+            <a:endParaRPr lang="en-US"/>
+          </a:p>
+        </p:txBody>
+      </p:sp>
+      <p:sp>
+        <p:nvSpPr>
+          <p:cNvPr id="3" name="Date Placeholder 2"/>
+          <p:cNvSpPr>
+            <a:spLocks noGrp="1"/>
+          </p:cNvSpPr>
+          <p:nvPr>
+            <p:ph type="dt" idx="1"/>
+          </p:nvPr>
+        </p:nvSpPr>
+        <p:spPr>
+          <a:xfrm>
+            <a:off x="3884613" y="0"/>
+            <a:ext cx="2971800" cy="458788"/>
+          </a:xfrm>
+          <a:prstGeom prst="rect">
+            <a:avLst/>
+          </a:prstGeom>
+        </p:spPr>
+        <p:txBody>
+          <a:bodyPr vert="horz" lIns="91440" tIns="45720" rIns="91440" bIns="45720" rtlCol="0"/>
+          <a:lstStyle>
+            <a:lvl1pPr algn="r">
+              <a:defRPr sz="1200"/>
+            </a:lvl1pPr>
+          </a:lstStyle>
+          <a:p>
+            <a:fld id="{24BD3927-2E27-CB4C-B99E-4488BCB53ACA}" type="datetimeFigureOut">
+              <a:rPr lang="en-US" smtClean="0"/>
+              <a:t>3/23/26</a:t>
+            </a:fld>
+            <a:endParaRPr lang="en-US"/>
+          </a:p>
+        </p:txBody>
+      </p:sp>
+      <p:sp>
+        <p:nvSpPr>
+          <p:cNvPr id="4" name="Slide Image Placeholder 3"/>
+          <p:cNvSpPr>
+            <a:spLocks noGrp="1" noRot="1" noChangeAspect="1"/>
+          </p:cNvSpPr>
+          <p:nvPr>
+            <p:ph type="sldImg" idx="2"/>
+          </p:nvPr>
+        </p:nvSpPr>
+        <p:spPr>
+          <a:xfrm>
+            <a:off x="685800" y="1143000"/>
+            <a:ext cx="5486400" cy="3086100"/>
+          </a:xfrm>
+          <a:prstGeom prst="rect">
+            <a:avLst/>
+          </a:prstGeom>
+          <a:noFill/>
+          <a:ln w="12700">
+            <a:solidFill>
+              <a:prstClr val="black"/>
+            </a:solidFill>
+          </a:ln>
+        </p:spPr>
+        <p:txBody>
+          <a:bodyPr vert="horz" lIns="91440" tIns="45720" rIns="91440" bIns="45720" rtlCol="0" anchor="ctr"/>
+          <a:lstStyle/>
+          <a:p>
+            <a:endParaRPr lang="en-US"/>
+          </a:p>
+        </p:txBody>
+      </p:sp>
+      <p:sp>
+        <p:nvSpPr>
+          <p:cNvPr id="5" name="Notes Placeholder 4"/>
+          <p:cNvSpPr>
+            <a:spLocks noGrp="1"/>
+          </p:cNvSpPr>
+          <p:nvPr>
+            <p:ph type="body" sz="quarter" idx="3"/>
+          </p:nvPr>
+        </p:nvSpPr>
+        <p:spPr>
+          <a:xfrm>
+            <a:off x="685800" y="4400550"/>
+            <a:ext cx="5486400" cy="3600450"/>
+          </a:xfrm>
+          <a:prstGeom prst="rect">
+            <a:avLst/>
+          </a:prstGeom>
+        </p:spPr>
+        <p:txBody>
+          <a:bodyPr vert="horz" lIns="91440" tIns="45720" rIns="91440" bIns="45720" rtlCol="0"/>
+          <a:lstStyle/>
+          <a:p>
+            <a:pPr lvl="0"/>
+            <a:r>
+              <a:rPr lang="en-US"/>
+              <a:t>Click to edit Master text styles</a:t>
+            </a:r>
+          </a:p>
+          <a:p>
+            <a:pPr lvl="1"/>
+            <a:r>
+              <a:rPr lang="en-US"/>
+              <a:t>Second level</a:t>
+            </a:r>
+          </a:p>
+          <a:p>
+            <a:pPr lvl="2"/>
+            <a:r>
+              <a:rPr lang="en-US"/>
+              <a:t>Third level</a:t>
+            </a:r>
+          </a:p>
+          <a:p>
+            <a:pPr lvl="3"/>
+            <a:r>
+              <a:rPr lang="en-US"/>
+              <a:t>Fourth level</a:t>
+            </a:r>
+          </a:p>
+          <a:p>
+            <a:pPr lvl="4"/>
+            <a:r>
+              <a:rPr lang="en-US"/>
+              <a:t>Fifth level</a:t>
+            </a:r>
+          </a:p>
+        </p:txBody>
+      </p:sp>
+      <p:sp>
+        <p:nvSpPr>
+          <p:cNvPr id="6" name="Footer Placeholder 5"/>
+          <p:cNvSpPr>
+            <a:spLocks noGrp="1"/>
+          </p:cNvSpPr>
+          <p:nvPr>
+            <p:ph type="ftr" sz="quarter" idx="4"/>
+          </p:nvPr>
+        </p:nvSpPr>
+        <p:spPr>
+          <a:xfrm>
+            <a:off x="0" y="8685213"/>
+            <a:ext cx="2971800" cy="458787"/>
+          </a:xfrm>
+          <a:prstGeom prst="rect">
+            <a:avLst/>
+          </a:prstGeom>
+        </p:spPr>
+        <p:txBody>
+          <a:bodyPr vert="horz" lIns="91440" tIns="45720" rIns="91440" bIns="45720" rtlCol="0" anchor="b"/>
+          <a:lstStyle>
+            <a:lvl1pPr algn="l">
+              <a:defRPr sz="1200"/>
+            </a:lvl1pPr>
+          </a:lstStyle>
+          <a:p>
+            <a:endParaRPr lang="en-US"/>
+          </a:p>
+        </p:txBody>
+      </p:sp>
+      <p:sp>
+        <p:nvSpPr>
+          <p:cNvPr id="7" name="Slide Number Placeholder 6"/>
+          <p:cNvSpPr>
+            <a:spLocks noGrp="1"/>
+          </p:cNvSpPr>
+          <p:nvPr>
+            <p:ph type="sldNum" sz="quarter" idx="5"/>
+          </p:nvPr>
+        </p:nvSpPr>
+        <p:spPr>
+          <a:xfrm>
+            <a:off x="3884613" y="8685213"/>
+            <a:ext cx="2971800" cy="458787"/>
+          </a:xfrm>
+          <a:prstGeom prst="rect">
+            <a:avLst/>
+          </a:prstGeom>
+        </p:spPr>
+        <p:txBody>
+          <a:bodyPr vert="horz" lIns="91440" tIns="45720" rIns="91440" bIns="45720" rtlCol="0" anchor="b"/>
+          <a:lstStyle>
+            <a:lvl1pPr algn="r">
+              <a:defRPr sz="1200"/>
+            </a:lvl1pPr>
+          </a:lstStyle>
+          <a:p>
+            <a:fld id="{2F865CF1-5332-6B44-9C29-CEB1D3DFC2D7}" type="slidenum">
+              <a:rPr lang="en-US" smtClean="0"/>
+              <a:t>‹#›</a:t>
+            </a:fld>
+            <a:endParaRPr lang="en-US"/>
+          </a:p>
+        </p:txBody>
+      </p:sp>
+    </p:spTree>
+    <p:extLst>
+      <p:ext uri="{BB962C8B-B14F-4D97-AF65-F5344CB8AC3E}">
+        <p14:creationId xmlns:p14="http://schemas.microsoft.com/office/powerpoint/2010/main" val="2744026588"/>
+      </p:ext>
+    </p:extLst>
+  </p:cSld>
+  <p:clrMap bg1="lt1" tx1="dk1" bg2="lt2" tx2="dk2" accent1="accent1" accent2="accent2" accent3="accent3" accent4="accent4" accent5="accent5" accent6="accent6" hlink="hlink" folHlink="folHlink"/>
+  <p:notesStyle>
+    <a:lvl1pPr marL="0" algn="l" defTabSz="914400" rtl="0" eaLnBrk="1" latinLnBrk="0" hangingPunct="1">
+      <a:defRPr sz="1200" kern="1200">
+        <a:solidFill>
+          <a:schemeClr val="tx1"/>
+        </a:solidFill>
+        <a:latin typeface="+mn-lt"/>
+        <a:ea typeface="+mn-ea"/>
+        <a:cs typeface="+mn-cs"/>
+      </a:defRPr>
+    </a:lvl1pPr>
+    <a:lvl2pPr marL="457200" algn="l" defTabSz="914400" rtl="0" eaLnBrk="1" latinLnBrk="0" hangingPunct="1">
+      <a:defRPr sz="1200" kern="1200">
+        <a:solidFill>
+          <a:schemeClr val="tx1"/>
+        </a:solidFill>
+        <a:latin typeface="+mn-lt"/>
+        <a:ea typeface="+mn-ea"/>
+        <a:cs typeface="+mn-cs"/>
+      </a:defRPr>
+    </a:lvl2pPr>
+    <a:lvl3pPr marL="914400" algn="l" defTabSz="914400" rtl="0" eaLnBrk="1" latinLnBrk="0" hangingPunct="1">
+      <a:defRPr sz="1200" kern="1200">
+        <a:solidFill>
+          <a:schemeClr val="tx1"/>
+        </a:solidFill>
+        <a:latin typeface="+mn-lt"/>
+        <a:ea typeface="+mn-ea"/>
+        <a:cs typeface="+mn-cs"/>
+      </a:defRPr>
+    </a:lvl3pPr>
+    <a:lvl4pPr marL="1371600" algn="l" defTabSz="914400" rtl="0" eaLnBrk="1" latinLnBrk="0" hangingPunct="1">
+      <a:defRPr sz="1200" kern="1200">
+        <a:solidFill>
+          <a:schemeClr val="tx1"/>
+        </a:solidFill>
+        <a:latin typeface="+mn-lt"/>
+        <a:ea typeface="+mn-ea"/>
+        <a:cs typeface="+mn-cs"/>
+      </a:defRPr>
+    </a:lvl4pPr>
+    <a:lvl5pPr marL="1828800" algn="l" defTabSz="914400" rtl="0" eaLnBrk="1" latinLnBrk="0" hangingPunct="1">
+      <a:defRPr sz="1200" kern="1200">
+        <a:solidFill>
+          <a:schemeClr val="tx1"/>
+        </a:solidFill>
+        <a:latin typeface="+mn-lt"/>
+        <a:ea typeface="+mn-ea"/>
+        <a:cs typeface="+mn-cs"/>
+      </a:defRPr>
+    </a:lvl5pPr>
+    <a:lvl6pPr marL="2286000" algn="l" defTabSz="914400" rtl="0" eaLnBrk="1" latinLnBrk="0" hangingPunct="1">
+      <a:defRPr sz="1200" kern="1200">
+        <a:solidFill>
+          <a:schemeClr val="tx1"/>
+        </a:solidFill>
+        <a:latin typeface="+mn-lt"/>
+        <a:ea typeface="+mn-ea"/>
+        <a:cs typeface="+mn-cs"/>
+      </a:defRPr>
+    </a:lvl6pPr>
+    <a:lvl7pPr marL="2743200" algn="l" defTabSz="914400" rtl="0" eaLnBrk="1" latinLnBrk="0" hangingPunct="1">
+      <a:defRPr sz="1200" kern="1200">
+        <a:solidFill>
+          <a:schemeClr val="tx1"/>
+        </a:solidFill>
+        <a:latin typeface="+mn-lt"/>
+        <a:ea typeface="+mn-ea"/>
+        <a:cs typeface="+mn-cs"/>
+      </a:defRPr>
+    </a:lvl7pPr>
+    <a:lvl8pPr marL="3200400" algn="l" defTabSz="914400" rtl="0" eaLnBrk="1" latinLnBrk="0" hangingPunct="1">
+      <a:defRPr sz="1200" kern="1200">
+        <a:solidFill>
+          <a:schemeClr val="tx1"/>
+        </a:solidFill>
+        <a:latin typeface="+mn-lt"/>
+        <a:ea typeface="+mn-ea"/>
+        <a:cs typeface="+mn-cs"/>
+      </a:defRPr>
+    </a:lvl8pPr>
+    <a:lvl9pPr marL="3657600" algn="l" defTabSz="914400" rtl="0" eaLnBrk="1" latinLnBrk="0" hangingPunct="1">
+      <a:defRPr sz="1200" kern="1200">
+        <a:solidFill>
+          <a:schemeClr val="tx1"/>
+        </a:solidFill>
+        <a:latin typeface="+mn-lt"/>
+        <a:ea typeface="+mn-ea"/>
+        <a:cs typeface="+mn-cs"/>
+      </a:defRPr>
+    </a:lvl9pPr>
+  </p:notesStyle>
+</p:notesMaster>
+</file>
+
+<file path=ppt/notesSlides/notesSlide1.xml><?xml version="1.0" encoding="utf-8"?>
+<p:notes xmlns:a="http://schemas.openxmlformats.org/drawingml/2006/main" xmlns:r="http://schemas.openxmlformats.org/officeDocument/2006/relationships" xmlns:p="http://schemas.openxmlformats.org/presentationml/2006/main">
+  <p:cSld>
+    <p:spTree>
+      <p:nvGrpSpPr>
+        <p:cNvPr id="1" name=""/>
+        <p:cNvGrpSpPr/>
+        <p:nvPr/>
+      </p:nvGrpSpPr>
+      <p:grpSpPr>
+        <a:xfrm>
+          <a:off x="0" y="0"/>
+          <a:ext cx="0" cy="0"/>
+          <a:chOff x="0" y="0"/>
+          <a:chExt cx="0" cy="0"/>
+        </a:xfrm>
+      </p:grpSpPr>
+      <p:sp>
+        <p:nvSpPr>
+          <p:cNvPr id="2" name="Slide Image Placeholder 1"/>
+          <p:cNvSpPr>
+            <a:spLocks noGrp="1" noRot="1" noChangeAspect="1"/>
+          </p:cNvSpPr>
+          <p:nvPr>
+            <p:ph type="sldImg"/>
+          </p:nvPr>
+        </p:nvSpPr>
+        <p:spPr/>
+      </p:sp>
+      <p:sp>
+        <p:nvSpPr>
+          <p:cNvPr id="3" name="Notes Placeholder 2"/>
+          <p:cNvSpPr>
+            <a:spLocks noGrp="1"/>
+          </p:cNvSpPr>
+          <p:nvPr>
+            <p:ph type="body" idx="1"/>
+          </p:nvPr>
+        </p:nvSpPr>
+        <p:spPr/>
+        <p:txBody>
+          <a:bodyPr/>
+          <a:lstStyle/>
+          <a:p>
+            <a:endParaRPr lang="en-US" dirty="0"/>
+          </a:p>
+        </p:txBody>
+      </p:sp>
+      <p:sp>
+        <p:nvSpPr>
+          <p:cNvPr id="4" name="Slide Number Placeholder 3"/>
+          <p:cNvSpPr>
+            <a:spLocks noGrp="1"/>
+          </p:cNvSpPr>
+          <p:nvPr>
+            <p:ph type="sldNum" sz="quarter" idx="5"/>
+          </p:nvPr>
+        </p:nvSpPr>
+        <p:spPr/>
+        <p:txBody>
+          <a:bodyPr/>
+          <a:lstStyle/>
+          <a:p>
+            <a:fld id="{2F865CF1-5332-6B44-9C29-CEB1D3DFC2D7}" type="slidenum">
+              <a:rPr lang="en-US" smtClean="0"/>
+              <a:t>1</a:t>
+            </a:fld>
+            <a:endParaRPr lang="en-US"/>
+          </a:p>
+        </p:txBody>
+      </p:sp>
+    </p:spTree>
+    <p:extLst>
+      <p:ext uri="{BB962C8B-B14F-4D97-AF65-F5344CB8AC3E}">
+        <p14:creationId xmlns:p14="http://schemas.microsoft.com/office/powerpoint/2010/main" val="2979678379"/>
+      </p:ext>
+    </p:extLst>
+  </p:cSld>
+  <p:clrMapOvr>
+    <a:masterClrMapping/>
+  </p:clrMapOvr>
+</p:notes>
 </file>
 
 <file path=ppt/slideLayouts/slideLayout1.xml><?xml version="1.0" encoding="utf-8"?>
@@ -263,7 +703,7 @@
           <a:p>
             <a:fld id="{738F159B-C9C1-FD46-A557-E92908D6FED3}" type="datetimeFigureOut">
               <a:rPr lang="en-US" smtClean="0"/>
-              <a:t>3/21/26</a:t>
+              <a:t>3/23/26</a:t>
             </a:fld>
             <a:endParaRPr lang="en-US"/>
           </a:p>
@@ -461,7 +901,7 @@
           <a:p>
             <a:fld id="{738F159B-C9C1-FD46-A557-E92908D6FED3}" type="datetimeFigureOut">
               <a:rPr lang="en-US" smtClean="0"/>
-              <a:t>3/21/26</a:t>
+              <a:t>3/23/26</a:t>
             </a:fld>
             <a:endParaRPr lang="en-US"/>
           </a:p>
@@ -669,7 +1109,7 @@
           <a:p>
             <a:fld id="{738F159B-C9C1-FD46-A557-E92908D6FED3}" type="datetimeFigureOut">
               <a:rPr lang="en-US" smtClean="0"/>
-              <a:t>3/21/26</a:t>
+              <a:t>3/23/26</a:t>
             </a:fld>
             <a:endParaRPr lang="en-US"/>
           </a:p>
@@ -867,7 +1307,7 @@
           <a:p>
             <a:fld id="{738F159B-C9C1-FD46-A557-E92908D6FED3}" type="datetimeFigureOut">
               <a:rPr lang="en-US" smtClean="0"/>
-              <a:t>3/21/26</a:t>
+              <a:t>3/23/26</a:t>
             </a:fld>
             <a:endParaRPr lang="en-US"/>
           </a:p>
@@ -1142,7 +1582,7 @@
           <a:p>
             <a:fld id="{738F159B-C9C1-FD46-A557-E92908D6FED3}" type="datetimeFigureOut">
               <a:rPr lang="en-US" smtClean="0"/>
-              <a:t>3/21/26</a:t>
+              <a:t>3/23/26</a:t>
             </a:fld>
             <a:endParaRPr lang="en-US"/>
           </a:p>
@@ -1407,7 +1847,7 @@
           <a:p>
             <a:fld id="{738F159B-C9C1-FD46-A557-E92908D6FED3}" type="datetimeFigureOut">
               <a:rPr lang="en-US" smtClean="0"/>
-              <a:t>3/21/26</a:t>
+              <a:t>3/23/26</a:t>
             </a:fld>
             <a:endParaRPr lang="en-US"/>
           </a:p>
@@ -1819,7 +2259,7 @@
           <a:p>
             <a:fld id="{738F159B-C9C1-FD46-A557-E92908D6FED3}" type="datetimeFigureOut">
               <a:rPr lang="en-US" smtClean="0"/>
-              <a:t>3/21/26</a:t>
+              <a:t>3/23/26</a:t>
             </a:fld>
             <a:endParaRPr lang="en-US"/>
           </a:p>
@@ -1960,7 +2400,7 @@
           <a:p>
             <a:fld id="{738F159B-C9C1-FD46-A557-E92908D6FED3}" type="datetimeFigureOut">
               <a:rPr lang="en-US" smtClean="0"/>
-              <a:t>3/21/26</a:t>
+              <a:t>3/23/26</a:t>
             </a:fld>
             <a:endParaRPr lang="en-US"/>
           </a:p>
@@ -2073,7 +2513,7 @@
           <a:p>
             <a:fld id="{738F159B-C9C1-FD46-A557-E92908D6FED3}" type="datetimeFigureOut">
               <a:rPr lang="en-US" smtClean="0"/>
-              <a:t>3/21/26</a:t>
+              <a:t>3/23/26</a:t>
             </a:fld>
             <a:endParaRPr lang="en-US"/>
           </a:p>
@@ -2384,7 +2824,7 @@
           <a:p>
             <a:fld id="{738F159B-C9C1-FD46-A557-E92908D6FED3}" type="datetimeFigureOut">
               <a:rPr lang="en-US" smtClean="0"/>
-              <a:t>3/21/26</a:t>
+              <a:t>3/23/26</a:t>
             </a:fld>
             <a:endParaRPr lang="en-US"/>
           </a:p>
@@ -2672,7 +3112,7 @@
           <a:p>
             <a:fld id="{738F159B-C9C1-FD46-A557-E92908D6FED3}" type="datetimeFigureOut">
               <a:rPr lang="en-US" smtClean="0"/>
-              <a:t>3/21/26</a:t>
+              <a:t>3/23/26</a:t>
             </a:fld>
             <a:endParaRPr lang="en-US"/>
           </a:p>
@@ -2913,7 +3353,7 @@
           <a:p>
             <a:fld id="{738F159B-C9C1-FD46-A557-E92908D6FED3}" type="datetimeFigureOut">
               <a:rPr lang="en-US" smtClean="0"/>
-              <a:t>3/21/26</a:t>
+              <a:t>3/23/26</a:t>
             </a:fld>
             <a:endParaRPr lang="en-US"/>
           </a:p>
@@ -3419,7 +3859,7 @@
                 <a14:useLocalDpi xmlns:a14="http://schemas.microsoft.com/office/drawing/2010/main" val="0"/>
               </a:ext>
               <a:ext uri="{96DAC541-7B7A-43D3-8B79-37D633B846F1}">
-                <asvg:svgBlip xmlns:asvg="http://schemas.microsoft.com/office/drawing/2016/SVG/main" r:embed="rId2"/>
+                <asvg:svgBlip xmlns:asvg="http://schemas.microsoft.com/office/drawing/2016/SVG/main" r:embed="rId3"/>
               </a:ext>
             </a:extLst>
           </a:blip>
@@ -3756,12 +4196,12 @@
           <a:p>
             <a:pPr algn="l"/>
             <a:r>
-              <a:rPr lang="en-US" sz="6600">
+              <a:rPr lang="en-US" sz="6600" dirty="0">
                 <a:solidFill>
                   <a:srgbClr val="FFFFFF"/>
                 </a:solidFill>
               </a:rPr>
-              <a:t>Solar Storm Prediction</a:t>
+              <a:t>Solar Storm Risk Prediction</a:t>
             </a:r>
           </a:p>
         </p:txBody>
@@ -3796,7 +4236,7 @@
           <a:p>
             <a:pPr algn="l"/>
             <a:r>
-              <a:rPr lang="en-US">
+              <a:rPr lang="en-US" dirty="0">
                 <a:solidFill>
                   <a:srgbClr val="FFFFFF"/>
                 </a:solidFill>
@@ -3807,12 +4247,39 @@
           <a:p>
             <a:pPr algn="l"/>
             <a:r>
-              <a:rPr lang="en-US">
+              <a:rPr lang="en-US" dirty="0">
                 <a:solidFill>
                   <a:srgbClr val="FFFFFF"/>
                 </a:solidFill>
               </a:rPr>
-              <a:t>Erdos Institute</a:t>
+              <a:t>Erd</a:t>
+            </a:r>
+            <a:r>
+              <a:rPr lang="en-US" dirty="0">
+                <a:solidFill>
+                  <a:schemeClr val="bg1"/>
+                </a:solidFill>
+              </a:rPr>
+              <a:t>ő</a:t>
+            </a:r>
+            <a:r>
+              <a:rPr lang="en-US" dirty="0">
+                <a:solidFill>
+                  <a:srgbClr val="FFFFFF"/>
+                </a:solidFill>
+              </a:rPr>
+              <a:t>s Institute </a:t>
+            </a:r>
+          </a:p>
+          <a:p>
+            <a:pPr algn="l"/>
+            <a:r>
+              <a:rPr lang="en-US" dirty="0">
+                <a:solidFill>
+                  <a:srgbClr val="FFFFFF"/>
+                </a:solidFill>
+              </a:rPr>
+              <a:t>Spring 2026 Data Science Bootcamp</a:t>
             </a:r>
           </a:p>
         </p:txBody>
@@ -4203,139 +4670,6 @@
 </p:sld>
 </file>
 
-<file path=ppt/slides/slide10.xml><?xml version="1.0" encoding="utf-8"?>
-<p:sld xmlns:a="http://schemas.openxmlformats.org/drawingml/2006/main" xmlns:r="http://schemas.openxmlformats.org/officeDocument/2006/relationships" xmlns:p="http://schemas.openxmlformats.org/presentationml/2006/main">
-  <p:cSld>
-    <p:spTree>
-      <p:nvGrpSpPr>
-        <p:cNvPr id="1" name=""/>
-        <p:cNvGrpSpPr/>
-        <p:nvPr/>
-      </p:nvGrpSpPr>
-      <p:grpSpPr>
-        <a:xfrm>
-          <a:off x="0" y="0"/>
-          <a:ext cx="0" cy="0"/>
-          <a:chOff x="0" y="0"/>
-          <a:chExt cx="0" cy="0"/>
-        </a:xfrm>
-      </p:grpSpPr>
-      <p:sp>
-        <p:nvSpPr>
-          <p:cNvPr id="2" name="Title 1">
-            <a:extLst>
-              <a:ext uri="{FF2B5EF4-FFF2-40B4-BE49-F238E27FC236}">
-                <a16:creationId xmlns:a16="http://schemas.microsoft.com/office/drawing/2014/main" id="{FFDD5978-D395-757C-6C9A-40581A758E0B}"/>
-              </a:ext>
-            </a:extLst>
-          </p:cNvPr>
-          <p:cNvSpPr>
-            <a:spLocks noGrp="1"/>
-          </p:cNvSpPr>
-          <p:nvPr>
-            <p:ph type="title"/>
-          </p:nvPr>
-        </p:nvSpPr>
-        <p:spPr/>
-        <p:txBody>
-          <a:bodyPr/>
-          <a:lstStyle/>
-          <a:p>
-            <a:r>
-              <a:rPr lang="en-US" dirty="0"/>
-              <a:t>Limitations and potential</a:t>
-            </a:r>
-          </a:p>
-        </p:txBody>
-      </p:sp>
-      <p:sp>
-        <p:nvSpPr>
-          <p:cNvPr id="3" name="Content Placeholder 2">
-            <a:extLst>
-              <a:ext uri="{FF2B5EF4-FFF2-40B4-BE49-F238E27FC236}">
-                <a16:creationId xmlns:a16="http://schemas.microsoft.com/office/drawing/2014/main" id="{5120363B-0DE3-E1B8-E3AA-CAF97F46C64C}"/>
-              </a:ext>
-            </a:extLst>
-          </p:cNvPr>
-          <p:cNvSpPr>
-            <a:spLocks noGrp="1"/>
-          </p:cNvSpPr>
-          <p:nvPr>
-            <p:ph idx="1"/>
-          </p:nvPr>
-        </p:nvSpPr>
-        <p:spPr/>
-        <p:txBody>
-          <a:bodyPr>
-            <a:normAutofit/>
-          </a:bodyPr>
-          <a:lstStyle/>
-          <a:p>
-            <a:r>
-              <a:rPr lang="en-US" dirty="0"/>
-              <a:t>Will give many false positives</a:t>
-            </a:r>
-          </a:p>
-          <a:p>
-            <a:r>
-              <a:rPr lang="en-US" dirty="0"/>
-              <a:t>Further time horizon predictions not realistic without additional data sources</a:t>
-            </a:r>
-          </a:p>
-          <a:p>
-            <a:pPr lvl="1"/>
-            <a:r>
-              <a:rPr lang="en-US" dirty="0"/>
-              <a:t>Optical data from sun</a:t>
-            </a:r>
-          </a:p>
-          <a:p>
-            <a:r>
-              <a:rPr lang="en-US" dirty="0"/>
-              <a:t>Model could be deployed with "online" data from NOAA</a:t>
-            </a:r>
-          </a:p>
-          <a:p>
-            <a:pPr lvl="1"/>
-            <a:r>
-              <a:rPr lang="en-US" dirty="0"/>
-              <a:t>Data ingestion built, but online deployment not developed for lack of time</a:t>
-            </a:r>
-          </a:p>
-          <a:p>
-            <a:r>
-              <a:rPr lang="en-US" dirty="0"/>
-              <a:t>Business use case</a:t>
-            </a:r>
-          </a:p>
-          <a:p>
-            <a:pPr lvl="1"/>
-            <a:r>
-              <a:rPr lang="en-US" dirty="0"/>
-              <a:t>Provide advanced warning of potential geomagnetic storm to grid operators</a:t>
-            </a:r>
-          </a:p>
-          <a:p>
-            <a:pPr marL="0" indent="0">
-              <a:buNone/>
-            </a:pPr>
-            <a:endParaRPr lang="en-US" dirty="0"/>
-          </a:p>
-        </p:txBody>
-      </p:sp>
-    </p:spTree>
-    <p:extLst>
-      <p:ext uri="{BB962C8B-B14F-4D97-AF65-F5344CB8AC3E}">
-        <p14:creationId xmlns:p14="http://schemas.microsoft.com/office/powerpoint/2010/main" val="2752045659"/>
-      </p:ext>
-    </p:extLst>
-  </p:cSld>
-  <p:clrMapOvr>
-    <a:masterClrMapping/>
-  </p:clrMapOvr>
-</p:sld>
-</file>
-
 <file path=ppt/slides/slide2.xml><?xml version="1.0" encoding="utf-8"?>
 <p:sld xmlns:a="http://schemas.openxmlformats.org/drawingml/2006/main" xmlns:r="http://schemas.openxmlformats.org/officeDocument/2006/relationships" xmlns:p="http://schemas.openxmlformats.org/presentationml/2006/main">
   <p:cSld>
@@ -4405,7 +4739,7 @@
           <a:p>
             <a:r>
               <a:rPr lang="en-US" dirty="0"/>
-              <a:t>Sun emits solar wind at the Earth </a:t>
+              <a:t>Sun emits solar wind towards the Earth </a:t>
             </a:r>
           </a:p>
           <a:p>
@@ -4528,7 +4862,7 @@
           <a:p>
             <a:r>
               <a:rPr lang="en-US" dirty="0"/>
-              <a:t>Weather is simply not 100% detectable</a:t>
+              <a:t>Weather is simply not 100% predictable.</a:t>
             </a:r>
           </a:p>
           <a:p>
@@ -4679,6 +5013,18 @@
               <a:t>NOAA: real time solar wind data</a:t>
             </a:r>
           </a:p>
+          <a:p>
+            <a:r>
+              <a:rPr lang="en-US" dirty="0"/>
+              <a:t>Satellite data can have gaps, so data must be appropriately cleaned </a:t>
+            </a:r>
+          </a:p>
+          <a:p>
+            <a:pPr marL="0" indent="0">
+              <a:buNone/>
+            </a:pPr>
+            <a:endParaRPr lang="en-US" dirty="0"/>
+          </a:p>
         </p:txBody>
       </p:sp>
       <p:pic>
@@ -4711,6 +5057,41 @@
           </a:prstGeom>
         </p:spPr>
       </p:pic>
+      <p:sp>
+        <p:nvSpPr>
+          <p:cNvPr id="5" name="TextBox 4">
+            <a:extLst>
+              <a:ext uri="{FF2B5EF4-FFF2-40B4-BE49-F238E27FC236}">
+                <a16:creationId xmlns:a16="http://schemas.microsoft.com/office/drawing/2014/main" id="{6620FD2A-A28A-A665-A974-CC0AFA83F0C6}"/>
+              </a:ext>
+            </a:extLst>
+          </p:cNvPr>
+          <p:cNvSpPr txBox="1"/>
+          <p:nvPr/>
+        </p:nvSpPr>
+        <p:spPr>
+          <a:xfrm>
+            <a:off x="6878721" y="5858358"/>
+            <a:ext cx="5216434" cy="369332"/>
+          </a:xfrm>
+          <a:prstGeom prst="rect">
+            <a:avLst/>
+          </a:prstGeom>
+          <a:noFill/>
+        </p:spPr>
+        <p:txBody>
+          <a:bodyPr wrap="square" rtlCol="0">
+            <a:spAutoFit/>
+          </a:bodyPr>
+          <a:lstStyle/>
+          <a:p>
+            <a:r>
+              <a:rPr lang="en-US" dirty="0"/>
+              <a:t>Photo credit: NASA</a:t>
+            </a:r>
+          </a:p>
+        </p:txBody>
+      </p:sp>
     </p:spTree>
     <p:extLst>
       <p:ext uri="{BB962C8B-B14F-4D97-AF65-F5344CB8AC3E}">
@@ -4746,7 +5127,7 @@
           <p:cNvPr id="2" name="Title 1">
             <a:extLst>
               <a:ext uri="{FF2B5EF4-FFF2-40B4-BE49-F238E27FC236}">
-                <a16:creationId xmlns:a16="http://schemas.microsoft.com/office/drawing/2014/main" id="{D2A8626C-51DF-7766-9AA8-8B1C4C444B50}"/>
+                <a16:creationId xmlns:a16="http://schemas.microsoft.com/office/drawing/2014/main" id="{A020B57B-3067-55D4-D1C7-DC02F1401207}"/>
               </a:ext>
             </a:extLst>
           </p:cNvPr>
@@ -4764,7 +5145,7 @@
           <a:p>
             <a:r>
               <a:rPr lang="en-US" dirty="0"/>
-              <a:t>NASA Data</a:t>
+              <a:t>Feature selection</a:t>
             </a:r>
           </a:p>
         </p:txBody>
@@ -4774,7 +5155,7 @@
           <p:cNvPr id="3" name="Content Placeholder 2">
             <a:extLst>
               <a:ext uri="{FF2B5EF4-FFF2-40B4-BE49-F238E27FC236}">
-                <a16:creationId xmlns:a16="http://schemas.microsoft.com/office/drawing/2014/main" id="{9A9954EB-B65B-857E-0D88-48DFF71225E5}"/>
+                <a16:creationId xmlns:a16="http://schemas.microsoft.com/office/drawing/2014/main" id="{7570D33D-B722-BB1A-DE4C-10A806F330F2}"/>
               </a:ext>
             </a:extLst>
           </p:cNvPr>
@@ -4787,24 +5168,69 @@
         </p:nvSpPr>
         <p:spPr/>
         <p:txBody>
-          <a:bodyPr/>
+          <a:bodyPr>
+            <a:normAutofit lnSpcReduction="10000"/>
+          </a:bodyPr>
           <a:lstStyle/>
           <a:p>
             <a:r>
               <a:rPr lang="en-US" dirty="0"/>
-              <a:t>NASA data is well-documented, but has some eccentricities that require basic cleaning</a:t>
-            </a:r>
-          </a:p>
-          <a:p>
+              <a:t>Physics informed features: </a:t>
+            </a:r>
+          </a:p>
+          <a:p>
+            <a:pPr lvl="1"/>
             <a:r>
               <a:rPr lang="en-US" dirty="0"/>
-              <a:t>Satellite data can have gaps, so data must be appropriately cleaned </a:t>
-            </a:r>
-          </a:p>
-          <a:p>
+              <a:t>Angle between solar wind and Earth's magnetic field</a:t>
+            </a:r>
+          </a:p>
+          <a:p>
+            <a:pPr lvl="1"/>
             <a:r>
               <a:rPr lang="en-US" dirty="0"/>
-              <a:t>Input features are hourly, but output response is a rolling 3 hour average</a:t>
+              <a:t>Energy flux</a:t>
+            </a:r>
+          </a:p>
+          <a:p>
+            <a:pPr lvl="1"/>
+            <a:r>
+              <a:rPr lang="en-US" dirty="0"/>
+              <a:t>Rolling averages of measurements</a:t>
+            </a:r>
+          </a:p>
+          <a:p>
+            <a:pPr lvl="1"/>
+            <a:r>
+              <a:rPr lang="en-US" dirty="0"/>
+              <a:t>Variation in magnetic orientation of solar wind</a:t>
+            </a:r>
+          </a:p>
+          <a:p>
+            <a:pPr lvl="1"/>
+            <a:r>
+              <a:rPr lang="en-US" dirty="0"/>
+              <a:t>"Newell coupling" </a:t>
+            </a:r>
+          </a:p>
+          <a:p>
+            <a:r>
+              <a:rPr lang="en-US" dirty="0"/>
+              <a:t>Some features were highly correlated, so they were dropped to improve model performance</a:t>
+            </a:r>
+          </a:p>
+          <a:p>
+            <a:pPr lvl="1"/>
+            <a:r>
+              <a:rPr lang="en-US" dirty="0"/>
+              <a:t>Many engineered rolling averages were too highly correlated with raw features.</a:t>
+            </a:r>
+          </a:p>
+          <a:p>
+            <a:pPr lvl="1"/>
+            <a:r>
+              <a:rPr lang="en-US" dirty="0"/>
+              <a:t>Features encoding solar wind vector had some redundancy and so a few were dropped.</a:t>
             </a:r>
           </a:p>
         </p:txBody>
@@ -4812,7 +5238,7 @@
     </p:spTree>
     <p:extLst>
       <p:ext uri="{BB962C8B-B14F-4D97-AF65-F5344CB8AC3E}">
-        <p14:creationId xmlns:p14="http://schemas.microsoft.com/office/powerpoint/2010/main" val="2173881900"/>
+        <p14:creationId xmlns:p14="http://schemas.microsoft.com/office/powerpoint/2010/main" val="2675967162"/>
       </p:ext>
     </p:extLst>
   </p:cSld>
@@ -4844,7 +5270,7 @@
           <p:cNvPr id="2" name="Title 1">
             <a:extLst>
               <a:ext uri="{FF2B5EF4-FFF2-40B4-BE49-F238E27FC236}">
-                <a16:creationId xmlns:a16="http://schemas.microsoft.com/office/drawing/2014/main" id="{A020B57B-3067-55D4-D1C7-DC02F1401207}"/>
+                <a16:creationId xmlns:a16="http://schemas.microsoft.com/office/drawing/2014/main" id="{61F277A0-780C-5748-03A3-CF49654F1A35}"/>
               </a:ext>
             </a:extLst>
           </p:cNvPr>
@@ -4862,7 +5288,7 @@
           <a:p>
             <a:r>
               <a:rPr lang="en-US" dirty="0"/>
-              <a:t>Feature selection</a:t>
+              <a:t>Model Selection</a:t>
             </a:r>
           </a:p>
         </p:txBody>
@@ -4872,7 +5298,7 @@
           <p:cNvPr id="3" name="Content Placeholder 2">
             <a:extLst>
               <a:ext uri="{FF2B5EF4-FFF2-40B4-BE49-F238E27FC236}">
-                <a16:creationId xmlns:a16="http://schemas.microsoft.com/office/drawing/2014/main" id="{7570D33D-B722-BB1A-DE4C-10A806F330F2}"/>
+                <a16:creationId xmlns:a16="http://schemas.microsoft.com/office/drawing/2014/main" id="{CBC9E8AB-E49A-A140-788B-D3E648F7C0E0}"/>
               </a:ext>
             </a:extLst>
           </p:cNvPr>
@@ -4886,68 +5312,85 @@
         <p:spPr/>
         <p:txBody>
           <a:bodyPr>
-            <a:normAutofit lnSpcReduction="10000"/>
+            <a:normAutofit fontScale="92500" lnSpcReduction="10000"/>
           </a:bodyPr>
           <a:lstStyle/>
           <a:p>
             <a:r>
               <a:rPr lang="en-US" dirty="0"/>
-              <a:t>Physics informed features: </a:t>
+              <a:t>Time series data</a:t>
             </a:r>
           </a:p>
           <a:p>
             <a:pPr lvl="1"/>
             <a:r>
               <a:rPr lang="en-US" dirty="0"/>
-              <a:t>Angle between solar wind and Earth's magnetic field</a:t>
+              <a:t>Used 20 years of historical data</a:t>
             </a:r>
           </a:p>
           <a:p>
             <a:pPr lvl="1"/>
             <a:r>
               <a:rPr lang="en-US" dirty="0"/>
-              <a:t>Energy flux</a:t>
+              <a:t>Cross-validation with 1 year folds</a:t>
+            </a:r>
+          </a:p>
+          <a:p>
+            <a:r>
+              <a:rPr lang="en-US" dirty="0"/>
+              <a:t>Weather prediction domain</a:t>
             </a:r>
           </a:p>
           <a:p>
             <a:pPr lvl="1"/>
             <a:r>
               <a:rPr lang="en-US" dirty="0"/>
-              <a:t>Rolling averages of measurements</a:t>
+              <a:t>Maximize recall with precision &gt;= .30</a:t>
             </a:r>
           </a:p>
           <a:p>
             <a:pPr lvl="1"/>
             <a:r>
               <a:rPr lang="en-US" dirty="0"/>
-              <a:t>Variation in magnetic orientation of solar wind</a:t>
+              <a:t>Maintain realistic expectations for results</a:t>
             </a:r>
           </a:p>
           <a:p>
             <a:pPr lvl="1"/>
             <a:r>
               <a:rPr lang="en-US" dirty="0"/>
-              <a:t>"Newell coupling" </a:t>
+              <a:t>Adjust probability threshold on models</a:t>
             </a:r>
           </a:p>
           <a:p>
             <a:r>
               <a:rPr lang="en-US" dirty="0"/>
-              <a:t>Some features were highly correlated, so they were dropped to improve model performance</a:t>
+              <a:t>Hyperparameter tuning using </a:t>
+            </a:r>
+            <a:r>
+              <a:rPr lang="en-US" dirty="0" err="1"/>
+              <a:t>Optuna</a:t>
+            </a:r>
+            <a:endParaRPr lang="en-US" dirty="0"/>
+          </a:p>
+          <a:p>
+            <a:r>
+              <a:rPr lang="en-US" dirty="0"/>
+              <a:t>Baselines</a:t>
             </a:r>
           </a:p>
           <a:p>
             <a:pPr lvl="1"/>
             <a:r>
               <a:rPr lang="en-US" dirty="0"/>
-              <a:t>Many engineered rolling averages were too highly correlated with raw features.</a:t>
+              <a:t>High precision 0 recall: Dummy classifier always says "No Storm"</a:t>
             </a:r>
           </a:p>
           <a:p>
             <a:pPr lvl="1"/>
             <a:r>
               <a:rPr lang="en-US" dirty="0"/>
-              <a:t>Features encoding solar wind vector had some redundancy and so a few were dropped.</a:t>
+              <a:t>Other standard models without feature engineering: &lt; 0.3 recall and &lt; 0.6 precision </a:t>
             </a:r>
           </a:p>
         </p:txBody>
@@ -4955,7 +5398,7 @@
     </p:spTree>
     <p:extLst>
       <p:ext uri="{BB962C8B-B14F-4D97-AF65-F5344CB8AC3E}">
-        <p14:creationId xmlns:p14="http://schemas.microsoft.com/office/powerpoint/2010/main" val="2675967162"/>
+        <p14:creationId xmlns:p14="http://schemas.microsoft.com/office/powerpoint/2010/main" val="60001393"/>
       </p:ext>
     </p:extLst>
   </p:cSld>
@@ -4987,7 +5430,7 @@
           <p:cNvPr id="2" name="Title 1">
             <a:extLst>
               <a:ext uri="{FF2B5EF4-FFF2-40B4-BE49-F238E27FC236}">
-                <a16:creationId xmlns:a16="http://schemas.microsoft.com/office/drawing/2014/main" id="{61F277A0-780C-5748-03A3-CF49654F1A35}"/>
+                <a16:creationId xmlns:a16="http://schemas.microsoft.com/office/drawing/2014/main" id="{27053901-B271-8387-BA37-6EBCAD2C668D}"/>
               </a:ext>
             </a:extLst>
           </p:cNvPr>
@@ -5005,7 +5448,15 @@
           <a:p>
             <a:r>
               <a:rPr lang="en-US" dirty="0"/>
-              <a:t>Model Selection</a:t>
+              <a:t>Results (</a:t>
+            </a:r>
+            <a:r>
+              <a:rPr lang="en-US" dirty="0" err="1"/>
+              <a:t>XGBClassifier</a:t>
+            </a:r>
+            <a:r>
+              <a:rPr lang="en-US" dirty="0"/>
+              <a:t>)</a:t>
             </a:r>
           </a:p>
         </p:txBody>
@@ -5015,7 +5466,7 @@
           <p:cNvPr id="3" name="Content Placeholder 2">
             <a:extLst>
               <a:ext uri="{FF2B5EF4-FFF2-40B4-BE49-F238E27FC236}">
-                <a16:creationId xmlns:a16="http://schemas.microsoft.com/office/drawing/2014/main" id="{CBC9E8AB-E49A-A140-788B-D3E648F7C0E0}"/>
+                <a16:creationId xmlns:a16="http://schemas.microsoft.com/office/drawing/2014/main" id="{8F640AAD-D18E-43C8-D634-628B7016FA02}"/>
               </a:ext>
             </a:extLst>
           </p:cNvPr>
@@ -5028,86 +5479,18 @@
         </p:nvSpPr>
         <p:spPr/>
         <p:txBody>
-          <a:bodyPr>
-            <a:normAutofit fontScale="92500" lnSpcReduction="10000"/>
-          </a:bodyPr>
+          <a:bodyPr/>
           <a:lstStyle/>
           <a:p>
             <a:r>
               <a:rPr lang="en-US" dirty="0"/>
-              <a:t>Time series data</a:t>
-            </a:r>
-          </a:p>
-          <a:p>
-            <a:pPr lvl="1"/>
+              <a:t>Overall Precision: 0.3260</a:t>
+            </a:r>
+          </a:p>
+          <a:p>
             <a:r>
               <a:rPr lang="en-US" dirty="0"/>
-              <a:t>Used 20 years of historical data</a:t>
-            </a:r>
-          </a:p>
-          <a:p>
-            <a:pPr lvl="1"/>
-            <a:r>
-              <a:rPr lang="en-US" dirty="0"/>
-              <a:t>Cross-validation with 1 year folds</a:t>
-            </a:r>
-          </a:p>
-          <a:p>
-            <a:r>
-              <a:rPr lang="en-US" dirty="0"/>
-              <a:t>Weather prediction domain</a:t>
-            </a:r>
-          </a:p>
-          <a:p>
-            <a:pPr lvl="1"/>
-            <a:r>
-              <a:rPr lang="en-US" dirty="0"/>
-              <a:t>Maximize recall with precision &gt;= .30</a:t>
-            </a:r>
-          </a:p>
-          <a:p>
-            <a:pPr lvl="1"/>
-            <a:r>
-              <a:rPr lang="en-US" dirty="0"/>
-              <a:t>Maintain realistic expectations for results</a:t>
-            </a:r>
-          </a:p>
-          <a:p>
-            <a:pPr lvl="1"/>
-            <a:r>
-              <a:rPr lang="en-US" dirty="0"/>
-              <a:t>Adjust probability threshold on models</a:t>
-            </a:r>
-          </a:p>
-          <a:p>
-            <a:r>
-              <a:rPr lang="en-US" dirty="0"/>
-              <a:t>Hyperparameter tuning using </a:t>
-            </a:r>
-            <a:r>
-              <a:rPr lang="en-US" dirty="0" err="1"/>
-              <a:t>Optuna</a:t>
-            </a:r>
-            <a:endParaRPr lang="en-US" dirty="0"/>
-          </a:p>
-          <a:p>
-            <a:r>
-              <a:rPr lang="en-US" dirty="0"/>
-              <a:t>Baselines</a:t>
-            </a:r>
-          </a:p>
-          <a:p>
-            <a:pPr lvl="1"/>
-            <a:r>
-              <a:rPr lang="en-US" dirty="0"/>
-              <a:t>High precision 0 recall: Dummy classifier always says "No Storm"</a:t>
-            </a:r>
-          </a:p>
-          <a:p>
-            <a:pPr lvl="1"/>
-            <a:r>
-              <a:rPr lang="en-US" dirty="0"/>
-              <a:t>Other standard models without feature engineering: &lt; 0.3 recall and &lt; 0.6 precision </a:t>
+              <a:t>Overall Recall : 0.7517</a:t>
             </a:r>
           </a:p>
         </p:txBody>
@@ -5115,7 +5498,7 @@
     </p:spTree>
     <p:extLst>
       <p:ext uri="{BB962C8B-B14F-4D97-AF65-F5344CB8AC3E}">
-        <p14:creationId xmlns:p14="http://schemas.microsoft.com/office/powerpoint/2010/main" val="60001393"/>
+        <p14:creationId xmlns:p14="http://schemas.microsoft.com/office/powerpoint/2010/main" val="3675090739"/>
       </p:ext>
     </p:extLst>
   </p:cSld>
@@ -5147,7 +5530,7 @@
           <p:cNvPr id="2" name="Title 1">
             <a:extLst>
               <a:ext uri="{FF2B5EF4-FFF2-40B4-BE49-F238E27FC236}">
-                <a16:creationId xmlns:a16="http://schemas.microsoft.com/office/drawing/2014/main" id="{27053901-B271-8387-BA37-6EBCAD2C668D}"/>
+                <a16:creationId xmlns:a16="http://schemas.microsoft.com/office/drawing/2014/main" id="{3AAC5A8C-BC50-E9E6-811B-C1B4900E59E3}"/>
               </a:ext>
             </a:extLst>
           </p:cNvPr>
@@ -5163,77 +5546,86 @@
           <a:bodyPr/>
           <a:lstStyle/>
           <a:p>
+            <a:endParaRPr lang="en-US"/>
+          </a:p>
+        </p:txBody>
+      </p:sp>
+      <p:pic>
+        <p:nvPicPr>
+          <p:cNvPr id="4" name="Content Placeholder 3">
+            <a:extLst>
+              <a:ext uri="{FF2B5EF4-FFF2-40B4-BE49-F238E27FC236}">
+                <a16:creationId xmlns:a16="http://schemas.microsoft.com/office/drawing/2014/main" id="{226D2E6D-F72A-15BE-574B-806174EC132B}"/>
+              </a:ext>
+            </a:extLst>
+          </p:cNvPr>
+          <p:cNvPicPr>
+            <a:picLocks noGrp="1" noChangeAspect="1"/>
+          </p:cNvPicPr>
+          <p:nvPr>
+            <p:ph idx="1"/>
+          </p:nvPr>
+        </p:nvPicPr>
+        <p:blipFill>
+          <a:blip r:embed="rId2"/>
+          <a:stretch>
+            <a:fillRect/>
+          </a:stretch>
+        </p:blipFill>
+        <p:spPr>
+          <a:xfrm>
+            <a:off x="2273068" y="-646362"/>
+            <a:ext cx="7645864" cy="6899928"/>
+          </a:xfrm>
+          <a:prstGeom prst="rect">
+            <a:avLst/>
+          </a:prstGeom>
+        </p:spPr>
+      </p:pic>
+      <p:sp>
+        <p:nvSpPr>
+          <p:cNvPr id="5" name="TextBox 4">
+            <a:extLst>
+              <a:ext uri="{FF2B5EF4-FFF2-40B4-BE49-F238E27FC236}">
+                <a16:creationId xmlns:a16="http://schemas.microsoft.com/office/drawing/2014/main" id="{4FC42D77-2131-6F91-E8ED-45CBE4BA61D8}"/>
+              </a:ext>
+            </a:extLst>
+          </p:cNvPr>
+          <p:cNvSpPr txBox="1"/>
+          <p:nvPr/>
+        </p:nvSpPr>
+        <p:spPr>
+          <a:xfrm>
+            <a:off x="4355025" y="6393050"/>
+            <a:ext cx="2603714" cy="369332"/>
+          </a:xfrm>
+          <a:prstGeom prst="rect">
+            <a:avLst/>
+          </a:prstGeom>
+          <a:noFill/>
+        </p:spPr>
+        <p:txBody>
+          <a:bodyPr wrap="square" rtlCol="0">
+            <a:spAutoFit/>
+          </a:bodyPr>
+          <a:lstStyle/>
+          <a:p>
             <a:r>
               <a:rPr lang="en-US" dirty="0"/>
-              <a:t>Results (</a:t>
+              <a:t>model-</a:t>
             </a:r>
             <a:r>
               <a:rPr lang="en-US" dirty="0" err="1"/>
-              <a:t>XGBClassifier</a:t>
-            </a:r>
-            <a:r>
-              <a:rPr lang="en-US" dirty="0"/>
-              <a:t>)</a:t>
-            </a:r>
-          </a:p>
-        </p:txBody>
-      </p:sp>
-      <p:sp>
-        <p:nvSpPr>
-          <p:cNvPr id="3" name="Content Placeholder 2">
-            <a:extLst>
-              <a:ext uri="{FF2B5EF4-FFF2-40B4-BE49-F238E27FC236}">
-                <a16:creationId xmlns:a16="http://schemas.microsoft.com/office/drawing/2014/main" id="{8F640AAD-D18E-43C8-D634-628B7016FA02}"/>
-              </a:ext>
-            </a:extLst>
-          </p:cNvPr>
-          <p:cNvSpPr>
-            <a:spLocks noGrp="1"/>
-          </p:cNvSpPr>
-          <p:nvPr>
-            <p:ph idx="1"/>
-          </p:nvPr>
-        </p:nvSpPr>
-        <p:spPr/>
-        <p:txBody>
-          <a:bodyPr/>
-          <a:lstStyle/>
-          <a:p>
-            <a:r>
-              <a:rPr lang="en-US" dirty="0"/>
-              <a:t>ROC-AUC        : 0.9620</a:t>
-            </a:r>
-          </a:p>
-          <a:p>
-            <a:r>
-              <a:rPr lang="en-US" dirty="0"/>
-              <a:t>Avg Precision  : 0.5706</a:t>
-            </a:r>
-          </a:p>
-          <a:p>
-            <a:r>
-              <a:rPr lang="en-US" dirty="0"/>
-              <a:t>Brier Score    : 0.0536</a:t>
-            </a:r>
-          </a:p>
-          <a:p>
-            <a:r>
-              <a:rPr lang="en-US" dirty="0"/>
-              <a:t>Overall Precision: 0.3260</a:t>
-            </a:r>
-          </a:p>
-          <a:p>
-            <a:r>
-              <a:rPr lang="en-US" dirty="0"/>
-              <a:t>Overall Recall : 0.7517</a:t>
-            </a:r>
+              <a:t>selection.ipynb</a:t>
+            </a:r>
+            <a:endParaRPr lang="en-US" dirty="0"/>
           </a:p>
         </p:txBody>
       </p:sp>
     </p:spTree>
     <p:extLst>
       <p:ext uri="{BB962C8B-B14F-4D97-AF65-F5344CB8AC3E}">
-        <p14:creationId xmlns:p14="http://schemas.microsoft.com/office/powerpoint/2010/main" val="3675090739"/>
+        <p14:creationId xmlns:p14="http://schemas.microsoft.com/office/powerpoint/2010/main" val="793305027"/>
       </p:ext>
     </p:extLst>
   </p:cSld>
@@ -5265,7 +5657,7 @@
           <p:cNvPr id="2" name="Title 1">
             <a:extLst>
               <a:ext uri="{FF2B5EF4-FFF2-40B4-BE49-F238E27FC236}">
-                <a16:creationId xmlns:a16="http://schemas.microsoft.com/office/drawing/2014/main" id="{3AAC5A8C-BC50-E9E6-811B-C1B4900E59E3}"/>
+                <a16:creationId xmlns:a16="http://schemas.microsoft.com/office/drawing/2014/main" id="{FFDD5978-D395-757C-6C9A-40581A758E0B}"/>
               </a:ext>
             </a:extLst>
           </p:cNvPr>
@@ -5281,78 +5673,84 @@
           <a:bodyPr/>
           <a:lstStyle/>
           <a:p>
-            <a:endParaRPr lang="en-US"/>
-          </a:p>
-        </p:txBody>
-      </p:sp>
-      <p:pic>
-        <p:nvPicPr>
-          <p:cNvPr id="4" name="Content Placeholder 3">
-            <a:extLst>
-              <a:ext uri="{FF2B5EF4-FFF2-40B4-BE49-F238E27FC236}">
-                <a16:creationId xmlns:a16="http://schemas.microsoft.com/office/drawing/2014/main" id="{226D2E6D-F72A-15BE-574B-806174EC132B}"/>
-              </a:ext>
-            </a:extLst>
-          </p:cNvPr>
-          <p:cNvPicPr>
-            <a:picLocks noGrp="1" noChangeAspect="1"/>
-          </p:cNvPicPr>
+            <a:r>
+              <a:rPr lang="en-US" dirty="0"/>
+              <a:t>Limitations and potential</a:t>
+            </a:r>
+          </a:p>
+        </p:txBody>
+      </p:sp>
+      <p:sp>
+        <p:nvSpPr>
+          <p:cNvPr id="3" name="Content Placeholder 2">
+            <a:extLst>
+              <a:ext uri="{FF2B5EF4-FFF2-40B4-BE49-F238E27FC236}">
+                <a16:creationId xmlns:a16="http://schemas.microsoft.com/office/drawing/2014/main" id="{5120363B-0DE3-E1B8-E3AA-CAF97F46C64C}"/>
+              </a:ext>
+            </a:extLst>
+          </p:cNvPr>
+          <p:cNvSpPr>
+            <a:spLocks noGrp="1"/>
+          </p:cNvSpPr>
           <p:nvPr>
             <p:ph idx="1"/>
           </p:nvPr>
-        </p:nvPicPr>
-        <p:blipFill>
-          <a:blip r:embed="rId2"/>
-          <a:stretch>
-            <a:fillRect/>
-          </a:stretch>
-        </p:blipFill>
-        <p:spPr>
-          <a:xfrm>
-            <a:off x="2273068" y="-646362"/>
-            <a:ext cx="7645864" cy="6899928"/>
-          </a:xfrm>
-          <a:prstGeom prst="rect">
-            <a:avLst/>
-          </a:prstGeom>
-        </p:spPr>
-      </p:pic>
-      <p:sp>
-        <p:nvSpPr>
-          <p:cNvPr id="5" name="TextBox 4">
-            <a:extLst>
-              <a:ext uri="{FF2B5EF4-FFF2-40B4-BE49-F238E27FC236}">
-                <a16:creationId xmlns:a16="http://schemas.microsoft.com/office/drawing/2014/main" id="{4FC42D77-2131-6F91-E8ED-45CBE4BA61D8}"/>
-              </a:ext>
-            </a:extLst>
-          </p:cNvPr>
-          <p:cNvSpPr txBox="1"/>
-          <p:nvPr/>
-        </p:nvSpPr>
-        <p:spPr>
-          <a:xfrm>
-            <a:off x="4355025" y="6393050"/>
-            <a:ext cx="2603714" cy="369332"/>
-          </a:xfrm>
-          <a:prstGeom prst="rect">
-            <a:avLst/>
-          </a:prstGeom>
-          <a:noFill/>
-        </p:spPr>
-        <p:txBody>
-          <a:bodyPr wrap="square" rtlCol="0">
-            <a:spAutoFit/>
+        </p:nvSpPr>
+        <p:spPr/>
+        <p:txBody>
+          <a:bodyPr>
+            <a:normAutofit/>
           </a:bodyPr>
           <a:lstStyle/>
           <a:p>
             <a:r>
               <a:rPr lang="en-US" dirty="0"/>
-              <a:t>model-</a:t>
-            </a:r>
-            <a:r>
-              <a:rPr lang="en-US" dirty="0" err="1"/>
-              <a:t>selection.ipynb</a:t>
-            </a:r>
+              <a:t>Will give many false positives</a:t>
+            </a:r>
+          </a:p>
+          <a:p>
+            <a:r>
+              <a:rPr lang="en-US" dirty="0"/>
+              <a:t>Further time horizon predictions not realistic without additional data sources</a:t>
+            </a:r>
+          </a:p>
+          <a:p>
+            <a:pPr lvl="1"/>
+            <a:r>
+              <a:rPr lang="en-US" dirty="0"/>
+              <a:t>Optical data from sun</a:t>
+            </a:r>
+          </a:p>
+          <a:p>
+            <a:r>
+              <a:rPr lang="en-US" dirty="0"/>
+              <a:t>Model could be deployed with "online" data from NOAA</a:t>
+            </a:r>
+          </a:p>
+          <a:p>
+            <a:pPr lvl="1"/>
+            <a:r>
+              <a:rPr lang="en-US" dirty="0"/>
+              <a:t>Data ingestion built, but online deployment not developed for lack of time</a:t>
+            </a:r>
+          </a:p>
+          <a:p>
+            <a:r>
+              <a:rPr lang="en-US" dirty="0"/>
+              <a:t>Business use case</a:t>
+            </a:r>
+          </a:p>
+          <a:p>
+            <a:pPr lvl="1"/>
+            <a:r>
+              <a:rPr lang="en-US" dirty="0"/>
+              <a:t>Provide advanced warning of potential geomagnetic storm to grid operators</a:t>
+            </a:r>
+          </a:p>
+          <a:p>
+            <a:pPr marL="0" indent="0">
+              <a:buNone/>
+            </a:pPr>
             <a:endParaRPr lang="en-US" dirty="0"/>
           </a:p>
         </p:txBody>
@@ -5360,7 +5758,7 @@
     </p:spTree>
     <p:extLst>
       <p:ext uri="{BB962C8B-B14F-4D97-AF65-F5344CB8AC3E}">
-        <p14:creationId xmlns:p14="http://schemas.microsoft.com/office/powerpoint/2010/main" val="793305027"/>
+        <p14:creationId xmlns:p14="http://schemas.microsoft.com/office/powerpoint/2010/main" val="2752045659"/>
       </p:ext>
     </p:extLst>
   </p:cSld>
@@ -5683,4 +6081,319 @@
     </a:ext>
   </a:extLst>
 </a:theme>
+</file>
+
+<file path=ppt/theme/theme2.xml><?xml version="1.0" encoding="utf-8"?>
+<a:theme xmlns:a="http://schemas.openxmlformats.org/drawingml/2006/main" name="Office Theme">
+  <a:themeElements>
+    <a:clrScheme name="Office">
+      <a:dk1>
+        <a:sysClr val="windowText" lastClr="000000"/>
+      </a:dk1>
+      <a:lt1>
+        <a:sysClr val="window" lastClr="FFFFFF"/>
+      </a:lt1>
+      <a:dk2>
+        <a:srgbClr val="0E2841"/>
+      </a:dk2>
+      <a:lt2>
+        <a:srgbClr val="E8E8E8"/>
+      </a:lt2>
+      <a:accent1>
+        <a:srgbClr val="156082"/>
+      </a:accent1>
+      <a:accent2>
+        <a:srgbClr val="E97132"/>
+      </a:accent2>
+      <a:accent3>
+        <a:srgbClr val="196B24"/>
+      </a:accent3>
+      <a:accent4>
+        <a:srgbClr val="0F9ED5"/>
+      </a:accent4>
+      <a:accent5>
+        <a:srgbClr val="A02B93"/>
+      </a:accent5>
+      <a:accent6>
+        <a:srgbClr val="4EA72E"/>
+      </a:accent6>
+      <a:hlink>
+        <a:srgbClr val="467886"/>
+      </a:hlink>
+      <a:folHlink>
+        <a:srgbClr val="96607D"/>
+      </a:folHlink>
+    </a:clrScheme>
+    <a:fontScheme name="Office">
+      <a:majorFont>
+        <a:latin typeface="Aptos Display" panose="02110004020202020204"/>
+        <a:ea typeface=""/>
+        <a:cs typeface=""/>
+        <a:font script="Jpan" typeface="游ゴシック Light"/>
+        <a:font script="Hang" typeface="맑은 고딕"/>
+        <a:font script="Hans" typeface="等线 Light"/>
+        <a:font script="Hant" typeface="新細明體"/>
+        <a:font script="Arab" typeface="Times New Roman"/>
+        <a:font script="Hebr" typeface="Times New Roman"/>
+        <a:font script="Thai" typeface="Angsana New"/>
+        <a:font script="Ethi" typeface="Nyala"/>
+        <a:font script="Beng" typeface="Vrinda"/>
+        <a:font script="Gujr" typeface="Shruti"/>
+        <a:font script="Khmr" typeface="MoolBoran"/>
+        <a:font script="Knda" typeface="Tunga"/>
+        <a:font script="Guru" typeface="Raavi"/>
+        <a:font script="Cans" typeface="Euphemia"/>
+        <a:font script="Cher" typeface="Plantagenet Cherokee"/>
+        <a:font script="Yiii" typeface="Microsoft Yi Baiti"/>
+        <a:font script="Tibt" typeface="Microsoft Himalaya"/>
+        <a:font script="Thaa" typeface="MV Boli"/>
+        <a:font script="Deva" typeface="Mangal"/>
+        <a:font script="Telu" typeface="Gautami"/>
+        <a:font script="Taml" typeface="Latha"/>
+        <a:font script="Syrc" typeface="Estrangelo Edessa"/>
+        <a:font script="Orya" typeface="Kalinga"/>
+        <a:font script="Mlym" typeface="Kartika"/>
+        <a:font script="Laoo" typeface="DokChampa"/>
+        <a:font script="Sinh" typeface="Iskoola Pota"/>
+        <a:font script="Mong" typeface="Mongolian Baiti"/>
+        <a:font script="Viet" typeface="Times New Roman"/>
+        <a:font script="Uigh" typeface="Microsoft Uighur"/>
+        <a:font script="Geor" typeface="Sylfaen"/>
+        <a:font script="Armn" typeface="Arial"/>
+        <a:font script="Bugi" typeface="Leelawadee UI"/>
+        <a:font script="Bopo" typeface="Microsoft JhengHei"/>
+        <a:font script="Java" typeface="Javanese Text"/>
+        <a:font script="Lisu" typeface="Segoe UI"/>
+        <a:font script="Mymr" typeface="Myanmar Text"/>
+        <a:font script="Nkoo" typeface="Ebrima"/>
+        <a:font script="Olck" typeface="Nirmala UI"/>
+        <a:font script="Osma" typeface="Ebrima"/>
+        <a:font script="Phag" typeface="Phagspa"/>
+        <a:font script="Syrn" typeface="Estrangelo Edessa"/>
+        <a:font script="Syrj" typeface="Estrangelo Edessa"/>
+        <a:font script="Syre" typeface="Estrangelo Edessa"/>
+        <a:font script="Sora" typeface="Nirmala UI"/>
+        <a:font script="Tale" typeface="Microsoft Tai Le"/>
+        <a:font script="Talu" typeface="Microsoft New Tai Lue"/>
+        <a:font script="Tfng" typeface="Ebrima"/>
+      </a:majorFont>
+      <a:minorFont>
+        <a:latin typeface="Aptos" panose="02110004020202020204"/>
+        <a:ea typeface=""/>
+        <a:cs typeface=""/>
+        <a:font script="Jpan" typeface="游ゴシック"/>
+        <a:font script="Hang" typeface="맑은 고딕"/>
+        <a:font script="Hans" typeface="等线"/>
+        <a:font script="Hant" typeface="新細明體"/>
+        <a:font script="Arab" typeface="Arial"/>
+        <a:font script="Hebr" typeface="Arial"/>
+        <a:font script="Thai" typeface="Cordia New"/>
+        <a:font script="Ethi" typeface="Nyala"/>
+        <a:font script="Beng" typeface="Vrinda"/>
+        <a:font script="Gujr" typeface="Shruti"/>
+        <a:font script="Khmr" typeface="DaunPenh"/>
+        <a:font script="Knda" typeface="Tunga"/>
+        <a:font script="Guru" typeface="Raavi"/>
+        <a:font script="Cans" typeface="Euphemia"/>
+        <a:font script="Cher" typeface="Plantagenet Cherokee"/>
+        <a:font script="Yiii" typeface="Microsoft Yi Baiti"/>
+        <a:font script="Tibt" typeface="Microsoft Himalaya"/>
+        <a:font script="Thaa" typeface="MV Boli"/>
+        <a:font script="Deva" typeface="Mangal"/>
+        <a:font script="Telu" typeface="Gautami"/>
+        <a:font script="Taml" typeface="Latha"/>
+        <a:font script="Syrc" typeface="Estrangelo Edessa"/>
+        <a:font script="Orya" typeface="Kalinga"/>
+        <a:font script="Mlym" typeface="Kartika"/>
+        <a:font script="Laoo" typeface="DokChampa"/>
+        <a:font script="Sinh" typeface="Iskoola Pota"/>
+        <a:font script="Mong" typeface="Mongolian Baiti"/>
+        <a:font script="Viet" typeface="Arial"/>
+        <a:font script="Uigh" typeface="Microsoft Uighur"/>
+        <a:font script="Geor" typeface="Sylfaen"/>
+        <a:font script="Armn" typeface="Arial"/>
+        <a:font script="Bugi" typeface="Leelawadee UI"/>
+        <a:font script="Bopo" typeface="Microsoft JhengHei"/>
+        <a:font script="Java" typeface="Javanese Text"/>
+        <a:font script="Lisu" typeface="Segoe UI"/>
+        <a:font script="Mymr" typeface="Myanmar Text"/>
+        <a:font script="Nkoo" typeface="Ebrima"/>
+        <a:font script="Olck" typeface="Nirmala UI"/>
+        <a:font script="Osma" typeface="Ebrima"/>
+        <a:font script="Phag" typeface="Phagspa"/>
+        <a:font script="Syrn" typeface="Estrangelo Edessa"/>
+        <a:font script="Syrj" typeface="Estrangelo Edessa"/>
+        <a:font script="Syre" typeface="Estrangelo Edessa"/>
+        <a:font script="Sora" typeface="Nirmala UI"/>
+        <a:font script="Tale" typeface="Microsoft Tai Le"/>
+        <a:font script="Talu" typeface="Microsoft New Tai Lue"/>
+        <a:font script="Tfng" typeface="Ebrima"/>
+      </a:minorFont>
+    </a:fontScheme>
+    <a:fmtScheme name="Office">
+      <a:fillStyleLst>
+        <a:solidFill>
+          <a:schemeClr val="phClr"/>
+        </a:solidFill>
+        <a:gradFill rotWithShape="1">
+          <a:gsLst>
+            <a:gs pos="0">
+              <a:schemeClr val="phClr">
+                <a:lumMod val="110000"/>
+                <a:satMod val="105000"/>
+                <a:tint val="67000"/>
+              </a:schemeClr>
+            </a:gs>
+            <a:gs pos="50000">
+              <a:schemeClr val="phClr">
+                <a:lumMod val="105000"/>
+                <a:satMod val="103000"/>
+                <a:tint val="73000"/>
+              </a:schemeClr>
+            </a:gs>
+            <a:gs pos="100000">
+              <a:schemeClr val="phClr">
+                <a:lumMod val="105000"/>
+                <a:satMod val="109000"/>
+                <a:tint val="81000"/>
+              </a:schemeClr>
+            </a:gs>
+          </a:gsLst>
+          <a:lin ang="5400000" scaled="0"/>
+        </a:gradFill>
+        <a:gradFill rotWithShape="1">
+          <a:gsLst>
+            <a:gs pos="0">
+              <a:schemeClr val="phClr">
+                <a:satMod val="103000"/>
+                <a:lumMod val="102000"/>
+                <a:tint val="94000"/>
+              </a:schemeClr>
+            </a:gs>
+            <a:gs pos="50000">
+              <a:schemeClr val="phClr">
+                <a:satMod val="110000"/>
+                <a:lumMod val="100000"/>
+                <a:shade val="100000"/>
+              </a:schemeClr>
+            </a:gs>
+            <a:gs pos="100000">
+              <a:schemeClr val="phClr">
+                <a:lumMod val="99000"/>
+                <a:satMod val="120000"/>
+                <a:shade val="78000"/>
+              </a:schemeClr>
+            </a:gs>
+          </a:gsLst>
+          <a:lin ang="5400000" scaled="0"/>
+        </a:gradFill>
+      </a:fillStyleLst>
+      <a:lnStyleLst>
+        <a:ln w="12700" cap="flat" cmpd="sng" algn="ctr">
+          <a:solidFill>
+            <a:schemeClr val="phClr"/>
+          </a:solidFill>
+          <a:prstDash val="solid"/>
+          <a:miter lim="800000"/>
+        </a:ln>
+        <a:ln w="19050" cap="flat" cmpd="sng" algn="ctr">
+          <a:solidFill>
+            <a:schemeClr val="phClr"/>
+          </a:solidFill>
+          <a:prstDash val="solid"/>
+          <a:miter lim="800000"/>
+        </a:ln>
+        <a:ln w="25400" cap="flat" cmpd="sng" algn="ctr">
+          <a:solidFill>
+            <a:schemeClr val="phClr"/>
+          </a:solidFill>
+          <a:prstDash val="solid"/>
+          <a:miter lim="800000"/>
+        </a:ln>
+      </a:lnStyleLst>
+      <a:effectStyleLst>
+        <a:effectStyle>
+          <a:effectLst/>
+        </a:effectStyle>
+        <a:effectStyle>
+          <a:effectLst/>
+        </a:effectStyle>
+        <a:effectStyle>
+          <a:effectLst>
+            <a:outerShdw blurRad="57150" dist="19050" dir="5400000" algn="ctr" rotWithShape="0">
+              <a:srgbClr val="000000">
+                <a:alpha val="63000"/>
+              </a:srgbClr>
+            </a:outerShdw>
+          </a:effectLst>
+        </a:effectStyle>
+      </a:effectStyleLst>
+      <a:bgFillStyleLst>
+        <a:solidFill>
+          <a:schemeClr val="phClr"/>
+        </a:solidFill>
+        <a:solidFill>
+          <a:schemeClr val="phClr">
+            <a:tint val="95000"/>
+            <a:satMod val="170000"/>
+          </a:schemeClr>
+        </a:solidFill>
+        <a:gradFill rotWithShape="1">
+          <a:gsLst>
+            <a:gs pos="0">
+              <a:schemeClr val="phClr">
+                <a:tint val="93000"/>
+                <a:satMod val="150000"/>
+                <a:shade val="98000"/>
+                <a:lumMod val="102000"/>
+              </a:schemeClr>
+            </a:gs>
+            <a:gs pos="50000">
+              <a:schemeClr val="phClr">
+                <a:tint val="98000"/>
+                <a:satMod val="130000"/>
+                <a:shade val="90000"/>
+                <a:lumMod val="103000"/>
+              </a:schemeClr>
+            </a:gs>
+            <a:gs pos="100000">
+              <a:schemeClr val="phClr">
+                <a:shade val="63000"/>
+                <a:satMod val="120000"/>
+              </a:schemeClr>
+            </a:gs>
+          </a:gsLst>
+          <a:lin ang="5400000" scaled="0"/>
+        </a:gradFill>
+      </a:bgFillStyleLst>
+    </a:fmtScheme>
+  </a:themeElements>
+  <a:objectDefaults>
+    <a:lnDef>
+      <a:spPr/>
+      <a:bodyPr/>
+      <a:lstStyle/>
+      <a:style>
+        <a:lnRef idx="2">
+          <a:schemeClr val="accent1"/>
+        </a:lnRef>
+        <a:fillRef idx="0">
+          <a:schemeClr val="accent1"/>
+        </a:fillRef>
+        <a:effectRef idx="1">
+          <a:schemeClr val="accent1"/>
+        </a:effectRef>
+        <a:fontRef idx="minor">
+          <a:schemeClr val="tx1"/>
+        </a:fontRef>
+      </a:style>
+    </a:lnDef>
+  </a:objectDefaults>
+  <a:extraClrSchemeLst/>
+  <a:extLst>
+    <a:ext uri="{05A4C25C-085E-4340-85A3-A5531E510DB2}">
+      <thm15:themeFamily xmlns:thm15="http://schemas.microsoft.com/office/thememl/2012/main" name="Office Theme" id="{2E142A2C-CD16-42D6-873A-C26D2A0506FA}" vid="{1BDDFF52-6CD6-40A5-AB3C-68EB2F1E4D0A}"/>
+    </a:ext>
+  </a:extLst>
+</a:theme>
 </file>
</xml_diff>